<commit_message>
docs: add AVA literature audit review update
</commit_message>
<xml_diff>
--- a/docs/review-pack/AVA_Evaluation_Review_Slides.pptx
+++ b/docs/review-pack/AVA_Evaluation_Review_Slides.pptx
@@ -25,6 +25,11 @@
     <p:sldId id="273" r:id="rId25"/>
     <p:sldId id="274" r:id="rId26"/>
     <p:sldId id="275" r:id="rId27"/>
+    <p:sldId id="276" r:id="rId28"/>
+    <p:sldId id="277" r:id="rId29"/>
+    <p:sldId id="278" r:id="rId30"/>
+    <p:sldId id="279" r:id="rId31"/>
+    <p:sldId id="280" r:id="rId32"/>
   </p:sldIdLst>
   <p:sldSz cx="12191695" cy="6858000" type="screen4x3"/>
   <p:notesSz cx="6858000" cy="9144000"/>
@@ -19204,6 +19209,1106 @@
             </a:pPr>
             <a:r>
               <a:t>What must pass before implementation?</a:t>
+            </a:r>
+          </a:p>
+        </p:txBody>
+      </p:sp>
+    </p:spTree>
+  </p:cSld>
+  <p:clrMapOvr>
+    <a:masterClrMapping/>
+  </p:clrMapOvr>
+</p:sld>
+</file>
+
+<file path=ppt/slides/slide21.xml><?xml version="1.0" encoding="utf-8"?>
+<p:sld xmlns:a="http://schemas.openxmlformats.org/drawingml/2006/main" xmlns:p="http://schemas.openxmlformats.org/presentationml/2006/main" xmlns:r="http://schemas.openxmlformats.org/officeDocument/2006/relationships">
+  <p:cSld>
+    <p:spTree>
+      <p:nvGrpSpPr>
+        <p:cNvPr id="1" name=""/>
+        <p:cNvGrpSpPr/>
+        <p:nvPr/>
+      </p:nvGrpSpPr>
+      <p:grpSpPr/>
+      <p:sp>
+        <p:nvSpPr>
+          <p:cNvPr id="2" name="Title 1"/>
+          <p:cNvSpPr>
+            <a:spLocks noGrp="1"/>
+          </p:cNvSpPr>
+          <p:nvPr>
+            <p:ph type="title"/>
+          </p:nvPr>
+        </p:nvSpPr>
+        <p:spPr/>
+        <p:txBody>
+          <a:bodyPr/>
+          <a:lstStyle/>
+          <a:p>
+            <a:r>
+              <a:rPr sz="2500" b="1">
+                <a:solidFill>
+                  <a:srgbClr val="264741"/>
+                </a:solidFill>
+                <a:latin typeface="Aptos"/>
+              </a:rPr>
+              <a:t>Pass 3 evidence • close overlaps</a:t>
+            </a:r>
+          </a:p>
+        </p:txBody>
+      </p:sp>
+      <p:sp>
+        <p:nvSpPr>
+          <p:cNvPr id="3" name="Content Placeholder 2"/>
+          <p:cNvSpPr>
+            <a:spLocks noGrp="1"/>
+          </p:cNvSpPr>
+          <p:nvPr>
+            <p:ph idx="1"/>
+          </p:nvPr>
+        </p:nvSpPr>
+        <p:spPr/>
+        <p:txBody>
+          <a:bodyPr wrap="square"/>
+          <a:lstStyle/>
+          <a:p>
+            <a:pPr>
+              <a:spcAft>
+                <a:spcPts val="1300"/>
+              </a:spcAft>
+              <a:defRPr sz="1800">
+                <a:solidFill>
+                  <a:srgbClr val="233033"/>
+                </a:solidFill>
+                <a:latin typeface="Aptos"/>
+              </a:defRPr>
+            </a:pPr>
+            <a:r>
+              <a:rPr sz="1800" b="1">
+                <a:solidFill>
+                  <a:srgbClr val="264741"/>
+                </a:solidFill>
+                <a:latin typeface="Aptos"/>
+              </a:rPr>
+              <a:t>Same-key commit and memory policy: </a:t>
+            </a:r>
+            <a:r>
+              <a:rPr sz="1700" b="0">
+                <a:solidFill>
+                  <a:srgbClr val="233033"/>
+                </a:solidFill>
+                <a:latin typeface="Aptos"/>
+              </a:rPr>
+              <a:t>MemTX v2: evidence-bearing same-slot conflict gate; 90 cases / 5 backbones. Shared store, not async replica convergence.</a:t>
+            </a:r>
+          </a:p>
+          <a:p>
+            <a:pPr>
+              <a:spcAft>
+                <a:spcPts val="1300"/>
+              </a:spcAft>
+              <a:defRPr sz="1800">
+                <a:solidFill>
+                  <a:srgbClr val="233033"/>
+                </a:solidFill>
+                <a:latin typeface="Aptos"/>
+              </a:defRPr>
+            </a:pPr>
+            <a:r>
+              <a:rPr sz="1800" b="1">
+                <a:solidFill>
+                  <a:srgbClr val="264741"/>
+                </a:solidFill>
+                <a:latin typeface="Aptos"/>
+              </a:rPr>
+              <a:t>Deferral is prior art: </a:t>
+            </a:r>
+            <a:r>
+              <a:rPr sz="1700" b="0">
+                <a:solidFill>
+                  <a:srgbClr val="233033"/>
+                </a:solidFill>
+                <a:latin typeface="Aptos"/>
+              </a:rPr>
+              <a:t>TARL v5: append / noop / revise / reject_conflict / defer_verify; 5,422 cases with gold next state.</a:t>
+            </a:r>
+          </a:p>
+          <a:p>
+            <a:pPr>
+              <a:spcAft>
+                <a:spcPts val="1300"/>
+              </a:spcAft>
+              <a:defRPr sz="1800">
+                <a:solidFill>
+                  <a:srgbClr val="233033"/>
+                </a:solidFill>
+                <a:latin typeface="Aptos"/>
+              </a:defRPr>
+            </a:pPr>
+            <a:r>
+              <a:rPr sz="1800" b="1">
+                <a:solidFill>
+                  <a:srgbClr val="264741"/>
+                </a:solidFill>
+                <a:latin typeface="Aptos"/>
+              </a:rPr>
+              <a:t>Classify then reconcile: </a:t>
+            </a:r>
+            <a:r>
+              <a:rPr sz="1700" b="0">
+                <a:solidFill>
+                  <a:srgbClr val="233033"/>
+                </a:solidFill>
+                <a:latin typeface="Aptos"/>
+              </a:rPr>
+              <a:t>LatticeMind v1: Credibility vs Coordination; 73/75 on a 75-case ConflictBank set, one model.</a:t>
+            </a:r>
+          </a:p>
+          <a:p>
+            <a:pPr>
+              <a:spcAft>
+                <a:spcPts val="1300"/>
+              </a:spcAft>
+              <a:defRPr sz="1800">
+                <a:solidFill>
+                  <a:srgbClr val="233033"/>
+                </a:solidFill>
+                <a:latin typeface="Aptos"/>
+              </a:defRPr>
+            </a:pPr>
+            <a:r>
+              <a:rPr sz="1800" b="1">
+                <a:solidFill>
+                  <a:srgbClr val="264741"/>
+                </a:solidFill>
+                <a:latin typeface="Aptos"/>
+              </a:rPr>
+              <a:t>Sources: </a:t>
+            </a:r>
+            <a:r>
+              <a:rPr sz="1700" b="0">
+                <a:solidFill>
+                  <a:srgbClr val="233033"/>
+                </a:solidFill>
+                <a:latin typeface="Aptos"/>
+              </a:rPr>
+              <a:t>arXiv:2607.23929v2 · 2608.03699v5 · 2608.08236v1</a:t>
+            </a:r>
+          </a:p>
+        </p:txBody>
+      </p:sp>
+      <p:sp>
+        <p:nvSpPr>
+          <p:cNvPr id="4" name="TextBox 3"/>
+          <p:cNvSpPr txBox="1"/>
+          <p:nvPr/>
+        </p:nvSpPr>
+        <p:spPr>
+          <a:xfrm>
+            <a:off x="411480" y="6327648"/>
+            <a:ext cx="10972800" cy="256032"/>
+          </a:xfrm>
+          <a:prstGeom prst="rect">
+            <a:avLst/>
+          </a:prstGeom>
+          <a:noFill/>
+        </p:spPr>
+        <p:txBody>
+          <a:bodyPr wrap="none">
+            <a:spAutoFit/>
+          </a:bodyPr>
+          <a:lstStyle/>
+          <a:p>
+            <a:pPr algn="r"/>
+            <a:r>
+              <a:rPr sz="900" b="1">
+                <a:solidFill>
+                  <a:srgbClr val="964630"/>
+                </a:solidFill>
+                <a:latin typeface="Aptos"/>
+              </a:rPr>
+              <a:t>CURRENT AUDIT NOTES • SELECTED SOURCES • NOVELTY UNRESOLVED</a:t>
+            </a:r>
+          </a:p>
+        </p:txBody>
+      </p:sp>
+    </p:spTree>
+  </p:cSld>
+  <p:clrMapOvr>
+    <a:masterClrMapping/>
+  </p:clrMapOvr>
+</p:sld>
+</file>
+
+<file path=ppt/slides/slide22.xml><?xml version="1.0" encoding="utf-8"?>
+<p:sld xmlns:a="http://schemas.openxmlformats.org/drawingml/2006/main" xmlns:p="http://schemas.openxmlformats.org/presentationml/2006/main" xmlns:r="http://schemas.openxmlformats.org/officeDocument/2006/relationships">
+  <p:cSld>
+    <p:spTree>
+      <p:nvGrpSpPr>
+        <p:cNvPr id="1" name=""/>
+        <p:cNvGrpSpPr/>
+        <p:nvPr/>
+      </p:nvGrpSpPr>
+      <p:grpSpPr/>
+      <p:sp>
+        <p:nvSpPr>
+          <p:cNvPr id="2" name="Title 1"/>
+          <p:cNvSpPr>
+            <a:spLocks noGrp="1"/>
+          </p:cNvSpPr>
+          <p:nvPr>
+            <p:ph type="title"/>
+          </p:nvPr>
+        </p:nvSpPr>
+        <p:spPr/>
+        <p:txBody>
+          <a:bodyPr/>
+          <a:lstStyle/>
+          <a:p>
+            <a:r>
+              <a:rPr sz="2500" b="1">
+                <a:solidFill>
+                  <a:srgbClr val="264741"/>
+                </a:solidFill>
+                <a:latin typeface="Aptos"/>
+              </a:rPr>
+              <a:t>Async delivery • measure what converges</a:t>
+            </a:r>
+          </a:p>
+        </p:txBody>
+      </p:sp>
+      <p:sp>
+        <p:nvSpPr>
+          <p:cNvPr id="3" name="Content Placeholder 2"/>
+          <p:cNvSpPr>
+            <a:spLocks noGrp="1"/>
+          </p:cNvSpPr>
+          <p:nvPr>
+            <p:ph idx="1"/>
+          </p:nvPr>
+        </p:nvSpPr>
+        <p:spPr/>
+        <p:txBody>
+          <a:bodyPr wrap="square"/>
+          <a:lstStyle/>
+          <a:p>
+            <a:pPr>
+              <a:spcAft>
+                <a:spcPts val="1300"/>
+              </a:spcAft>
+              <a:defRPr sz="1800">
+                <a:solidFill>
+                  <a:srgbClr val="233033"/>
+                </a:solidFill>
+                <a:latin typeface="Aptos"/>
+              </a:defRPr>
+            </a:pPr>
+            <a:r>
+              <a:rPr sz="1800" b="1">
+                <a:solidFill>
+                  <a:srgbClr val="264741"/>
+                </a:solidFill>
+                <a:latin typeface="Aptos"/>
+              </a:rPr>
+              <a:t>Direct async example: </a:t>
+            </a:r>
+            <a:r>
+              <a:rPr sz="1700" b="0">
+                <a:solidFill>
+                  <a:srgbClr val="233033"/>
+                </a:solidFill>
+                <a:latin typeface="Aptos"/>
+              </a:rPr>
+              <a:t>Governed Shared Memory v1: supersession 90/90 conditional on both writes landing; 98/200 overall.</a:t>
+            </a:r>
+          </a:p>
+          <a:p>
+            <a:pPr>
+              <a:spcAft>
+                <a:spcPts val="1300"/>
+              </a:spcAft>
+              <a:defRPr sz="1800">
+                <a:solidFill>
+                  <a:srgbClr val="233033"/>
+                </a:solidFill>
+                <a:latin typeface="Aptos"/>
+              </a:defRPr>
+            </a:pPr>
+            <a:r>
+              <a:rPr sz="1800" b="1">
+                <a:solidFill>
+                  <a:srgbClr val="264741"/>
+                </a:solidFill>
+                <a:latin typeface="Aptos"/>
+              </a:rPr>
+              <a:t>Admission matters: </a:t>
+            </a:r>
+            <a:r>
+              <a:rPr sz="1700" b="0">
+                <a:solidFill>
+                  <a:srgbClr val="233033"/>
+                </a:solidFill>
+                <a:latin typeface="Aptos"/>
+              </a:rPr>
+              <a:t>A synchronous dedup gate rejected 206/400 writes before the asynchronous detector; report gate and detector separately.</a:t>
+            </a:r>
+          </a:p>
+          <a:p>
+            <a:pPr>
+              <a:spcAft>
+                <a:spcPts val="1300"/>
+              </a:spcAft>
+              <a:defRPr sz="1800">
+                <a:solidFill>
+                  <a:srgbClr val="233033"/>
+                </a:solidFill>
+                <a:latin typeface="Aptos"/>
+              </a:defRPr>
+            </a:pPr>
+            <a:r>
+              <a:rPr sz="1800" b="1">
+                <a:solidFill>
+                  <a:srgbClr val="264741"/>
+                </a:solidFill>
+                <a:latin typeface="Aptos"/>
+              </a:rPr>
+              <a:t>Different system questions: </a:t>
+            </a:r>
+            <a:r>
+              <a:rPr sz="1700" b="0">
+                <a:solidFill>
+                  <a:srgbClr val="233033"/>
+                </a:solidFill>
+                <a:latin typeface="Aptos"/>
+              </a:rPr>
+              <a:t>CoAgent repairs plan invalidity; S-Bus rejects structural stale-read/write races; neither is same-key truth adjudication.</a:t>
+            </a:r>
+          </a:p>
+          <a:p>
+            <a:pPr>
+              <a:spcAft>
+                <a:spcPts val="1300"/>
+              </a:spcAft>
+              <a:defRPr sz="1800">
+                <a:solidFill>
+                  <a:srgbClr val="233033"/>
+                </a:solidFill>
+                <a:latin typeface="Aptos"/>
+              </a:defRPr>
+            </a:pPr>
+            <a:r>
+              <a:rPr sz="1800" b="1">
+                <a:solidFill>
+                  <a:srgbClr val="264741"/>
+                </a:solidFill>
+                <a:latin typeface="Aptos"/>
+              </a:rPr>
+              <a:t>MELD caution: </a:t>
+            </a:r>
+            <a:r>
+              <a:rPr sz="1700" b="0">
+                <a:solidFill>
+                  <a:srgbClr val="233033"/>
+                </a:solidFill>
+                <a:latin typeface="Aptos"/>
+              </a:rPr>
+              <a:t>Status convergence can coexist with order-sensitive live sets / retrieval: 112/200 orderings changed the live set.</a:t>
+            </a:r>
+          </a:p>
+        </p:txBody>
+      </p:sp>
+      <p:sp>
+        <p:nvSpPr>
+          <p:cNvPr id="4" name="TextBox 3"/>
+          <p:cNvSpPr txBox="1"/>
+          <p:nvPr/>
+        </p:nvSpPr>
+        <p:spPr>
+          <a:xfrm>
+            <a:off x="411480" y="6327648"/>
+            <a:ext cx="10972800" cy="256032"/>
+          </a:xfrm>
+          <a:prstGeom prst="rect">
+            <a:avLst/>
+          </a:prstGeom>
+          <a:noFill/>
+        </p:spPr>
+        <p:txBody>
+          <a:bodyPr wrap="none">
+            <a:spAutoFit/>
+          </a:bodyPr>
+          <a:lstStyle/>
+          <a:p>
+            <a:pPr algn="r"/>
+            <a:r>
+              <a:rPr sz="900" b="1">
+                <a:solidFill>
+                  <a:srgbClr val="964630"/>
+                </a:solidFill>
+                <a:latin typeface="Aptos"/>
+              </a:rPr>
+              <a:t>CURRENT AUDIT NOTES • SELECTED SOURCES • NOVELTY UNRESOLVED</a:t>
+            </a:r>
+          </a:p>
+        </p:txBody>
+      </p:sp>
+    </p:spTree>
+  </p:cSld>
+  <p:clrMapOvr>
+    <a:masterClrMapping/>
+  </p:clrMapOvr>
+</p:sld>
+</file>
+
+<file path=ppt/slides/slide23.xml><?xml version="1.0" encoding="utf-8"?>
+<p:sld xmlns:a="http://schemas.openxmlformats.org/drawingml/2006/main" xmlns:p="http://schemas.openxmlformats.org/presentationml/2006/main" xmlns:r="http://schemas.openxmlformats.org/officeDocument/2006/relationships">
+  <p:cSld>
+    <p:spTree>
+      <p:nvGrpSpPr>
+        <p:cNvPr id="1" name=""/>
+        <p:cNvGrpSpPr/>
+        <p:nvPr/>
+      </p:nvGrpSpPr>
+      <p:grpSpPr/>
+      <p:sp>
+        <p:nvSpPr>
+          <p:cNvPr id="2" name="Title 1"/>
+          <p:cNvSpPr>
+            <a:spLocks noGrp="1"/>
+          </p:cNvSpPr>
+          <p:nvPr>
+            <p:ph type="title"/>
+          </p:nvPr>
+        </p:nvSpPr>
+        <p:spPr/>
+        <p:txBody>
+          <a:bodyPr/>
+          <a:lstStyle/>
+          <a:p>
+            <a:r>
+              <a:rPr sz="2500" b="1">
+                <a:solidFill>
+                  <a:srgbClr val="264741"/>
+                </a:solidFill>
+                <a:latin typeface="Aptos"/>
+              </a:rPr>
+              <a:t>Strong overlap ≠ exact experiment</a:t>
+            </a:r>
+          </a:p>
+        </p:txBody>
+      </p:sp>
+      <p:sp>
+        <p:nvSpPr>
+          <p:cNvPr id="3" name="Content Placeholder 2"/>
+          <p:cNvSpPr>
+            <a:spLocks noGrp="1"/>
+          </p:cNvSpPr>
+          <p:nvPr>
+            <p:ph idx="1"/>
+          </p:nvPr>
+        </p:nvSpPr>
+        <p:spPr/>
+        <p:txBody>
+          <a:bodyPr wrap="square"/>
+          <a:lstStyle/>
+          <a:p>
+            <a:pPr>
+              <a:spcAft>
+                <a:spcPts val="1300"/>
+              </a:spcAft>
+              <a:defRPr sz="1800">
+                <a:solidFill>
+                  <a:srgbClr val="233033"/>
+                </a:solidFill>
+                <a:latin typeface="Aptos"/>
+              </a:defRPr>
+            </a:pPr>
+            <a:r>
+              <a:rPr sz="1800" b="1">
+                <a:solidFill>
+                  <a:srgbClr val="264741"/>
+                </a:solidFill>
+                <a:latin typeface="Aptos"/>
+              </a:rPr>
+              <a:t>StateFuse / TOKI: </a:t>
+            </a:r>
+            <a:r>
+              <a:rPr sz="1700" b="0">
+                <a:solidFill>
+                  <a:srgbClr val="233033"/>
+                </a:solidFill>
+                <a:latin typeface="Aptos"/>
+              </a:rPr>
+              <a:t>Conflict-preserving replicated history, projection/abstention, provenance, time-aware policies and confirmation already appear.</a:t>
+            </a:r>
+          </a:p>
+          <a:p>
+            <a:pPr>
+              <a:spcAft>
+                <a:spcPts val="1300"/>
+              </a:spcAft>
+              <a:defRPr sz="1800">
+                <a:solidFill>
+                  <a:srgbClr val="233033"/>
+                </a:solidFill>
+                <a:latin typeface="Aptos"/>
+              </a:defRPr>
+            </a:pPr>
+            <a:r>
+              <a:rPr sz="1800" b="1">
+                <a:solidFill>
+                  <a:srgbClr val="264741"/>
+                </a:solidFill>
+                <a:latin typeface="Aptos"/>
+              </a:rPr>
+              <a:t>StateFuse caveat: </a:t>
+            </a:r>
+            <a:r>
+              <a:rPr sz="1700" b="0">
+                <a:solidFill>
+                  <a:srgbClr val="233033"/>
+                </a:solidFill>
+                <a:latin typeface="Aptos"/>
+              </a:rPr>
+              <a:t>Same 282-case slice: Table 3 says 64.9%; prose says 97.5%. Unresolved discrepancy; controlled-loop numeric table not recovered.</a:t>
+            </a:r>
+          </a:p>
+          <a:p>
+            <a:pPr>
+              <a:spcAft>
+                <a:spcPts val="1300"/>
+              </a:spcAft>
+              <a:defRPr sz="1800">
+                <a:solidFill>
+                  <a:srgbClr val="233033"/>
+                </a:solidFill>
+                <a:latin typeface="Aptos"/>
+              </a:defRPr>
+            </a:pPr>
+            <a:r>
+              <a:rPr sz="1800" b="1">
+                <a:solidFill>
+                  <a:srgbClr val="264741"/>
+                </a:solidFill>
+                <a:latin typeface="Aptos"/>
+              </a:rPr>
+              <a:t>SCF scope: </a:t>
+            </a:r>
+            <a:r>
+              <a:rPr sz="1700" b="0">
+                <a:solidFill>
+                  <a:srgbClr val="233033"/>
+                </a:solidFill>
+                <a:latin typeface="Aptos"/>
+              </a:rPr>
+              <a:t>600 simulated workflow runs; 27.9% precision / 65.2% recall / 39.0% F1 / 100% completion. Intent prevention ≠ claim convergence.</a:t>
+            </a:r>
+          </a:p>
+          <a:p>
+            <a:pPr>
+              <a:spcAft>
+                <a:spcPts val="1300"/>
+              </a:spcAft>
+              <a:defRPr sz="1800">
+                <a:solidFill>
+                  <a:srgbClr val="233033"/>
+                </a:solidFill>
+                <a:latin typeface="Aptos"/>
+              </a:defRPr>
+            </a:pPr>
+            <a:r>
+              <a:rPr sz="1800" b="1">
+                <a:solidFill>
+                  <a:srgbClr val="264741"/>
+                </a:solidFill>
+                <a:latin typeface="Aptos"/>
+              </a:rPr>
+              <a:t>Survey / code benchmark: </a:t>
+            </a:r>
+            <a:r>
+              <a:rPr sz="1700" b="0">
+                <a:solidFill>
+                  <a:srgbClr val="233033"/>
+                </a:solidFill>
+                <a:latin typeface="Aptos"/>
+              </a:rPr>
+              <a:t>Always-On: scoped 435-work survey, not exhaustive. CodeCRDT 5–10% = preliminary 60/600 manual sample.</a:t>
+            </a:r>
+          </a:p>
+        </p:txBody>
+      </p:sp>
+      <p:sp>
+        <p:nvSpPr>
+          <p:cNvPr id="4" name="TextBox 3"/>
+          <p:cNvSpPr txBox="1"/>
+          <p:nvPr/>
+        </p:nvSpPr>
+        <p:spPr>
+          <a:xfrm>
+            <a:off x="411480" y="6327648"/>
+            <a:ext cx="10972800" cy="256032"/>
+          </a:xfrm>
+          <a:prstGeom prst="rect">
+            <a:avLst/>
+          </a:prstGeom>
+          <a:noFill/>
+        </p:spPr>
+        <p:txBody>
+          <a:bodyPr wrap="none">
+            <a:spAutoFit/>
+          </a:bodyPr>
+          <a:lstStyle/>
+          <a:p>
+            <a:pPr algn="r"/>
+            <a:r>
+              <a:rPr sz="900" b="1">
+                <a:solidFill>
+                  <a:srgbClr val="964630"/>
+                </a:solidFill>
+                <a:latin typeface="Aptos"/>
+              </a:rPr>
+              <a:t>CURRENT AUDIT NOTES • SELECTED SOURCES • NOVELTY UNRESOLVED</a:t>
+            </a:r>
+          </a:p>
+        </p:txBody>
+      </p:sp>
+    </p:spTree>
+  </p:cSld>
+  <p:clrMapOvr>
+    <a:masterClrMapping/>
+  </p:clrMapOvr>
+</p:sld>
+</file>
+
+<file path=ppt/slides/slide24.xml><?xml version="1.0" encoding="utf-8"?>
+<p:sld xmlns:a="http://schemas.openxmlformats.org/drawingml/2006/main" xmlns:p="http://schemas.openxmlformats.org/presentationml/2006/main" xmlns:r="http://schemas.openxmlformats.org/officeDocument/2006/relationships">
+  <p:cSld>
+    <p:spTree>
+      <p:nvGrpSpPr>
+        <p:cNvPr id="1" name=""/>
+        <p:cNvGrpSpPr/>
+        <p:nvPr/>
+      </p:nvGrpSpPr>
+      <p:grpSpPr/>
+      <p:sp>
+        <p:nvSpPr>
+          <p:cNvPr id="2" name="Title 1"/>
+          <p:cNvSpPr>
+            <a:spLocks noGrp="1"/>
+          </p:cNvSpPr>
+          <p:nvPr>
+            <p:ph type="title"/>
+          </p:nvPr>
+        </p:nvSpPr>
+        <p:spPr/>
+        <p:txBody>
+          <a:bodyPr/>
+          <a:lstStyle/>
+          <a:p>
+            <a:r>
+              <a:rPr sz="2500" b="1">
+                <a:solidFill>
+                  <a:srgbClr val="264741"/>
+                </a:solidFill>
+                <a:latin typeface="Aptos"/>
+              </a:rPr>
+              <a:t>Verification needs context</a:t>
+            </a:r>
+          </a:p>
+        </p:txBody>
+      </p:sp>
+      <p:sp>
+        <p:nvSpPr>
+          <p:cNvPr id="3" name="Content Placeholder 2"/>
+          <p:cNvSpPr>
+            <a:spLocks noGrp="1"/>
+          </p:cNvSpPr>
+          <p:nvPr>
+            <p:ph idx="1"/>
+          </p:nvPr>
+        </p:nvSpPr>
+        <p:spPr/>
+        <p:txBody>
+          <a:bodyPr wrap="square"/>
+          <a:lstStyle/>
+          <a:p>
+            <a:pPr>
+              <a:spcAft>
+                <a:spcPts val="1300"/>
+              </a:spcAft>
+              <a:defRPr sz="1800">
+                <a:solidFill>
+                  <a:srgbClr val="233033"/>
+                </a:solidFill>
+                <a:latin typeface="Aptos"/>
+              </a:defRPr>
+            </a:pPr>
+            <a:r>
+              <a:rPr sz="1800" b="1">
+                <a:solidFill>
+                  <a:srgbClr val="264741"/>
+                </a:solidFill>
+                <a:latin typeface="Aptos"/>
+              </a:rPr>
+              <a:t>Evidence-pair errors: </a:t>
+            </a:r>
+            <a:r>
+              <a:rPr sz="1700" b="0">
+                <a:solidFill>
+                  <a:srgbClr val="233033"/>
+                </a:solidFill>
+                <a:latin typeface="Aptos"/>
+              </a:rPr>
+              <a:t>ECon: weak-model recall limits; resolution may be unjustified or prior-informed.</a:t>
+            </a:r>
+          </a:p>
+          <a:p>
+            <a:pPr>
+              <a:spcAft>
+                <a:spcPts val="1300"/>
+              </a:spcAft>
+              <a:defRPr sz="1800">
+                <a:solidFill>
+                  <a:srgbClr val="233033"/>
+                </a:solidFill>
+                <a:latin typeface="Aptos"/>
+              </a:defRPr>
+            </a:pPr>
+            <a:r>
+              <a:rPr sz="1800" b="1">
+                <a:solidFill>
+                  <a:srgbClr val="264741"/>
+                </a:solidFill>
+                <a:latin typeface="Aptos"/>
+              </a:rPr>
+              <a:t>Reference mismatch: </a:t>
+            </a:r>
+            <a:r>
+              <a:rPr sz="1700" b="0">
+                <a:solidFill>
+                  <a:srgbClr val="233033"/>
+                </a:solidFill>
+                <a:latin typeface="Aptos"/>
+              </a:rPr>
+              <a:t>REF-NLI: 1,143 claim/evidence pairs, including ambiguous reference/context cases.</a:t>
+            </a:r>
+          </a:p>
+          <a:p>
+            <a:pPr>
+              <a:spcAft>
+                <a:spcPts val="1300"/>
+              </a:spcAft>
+              <a:defRPr sz="1800">
+                <a:solidFill>
+                  <a:srgbClr val="233033"/>
+                </a:solidFill>
+                <a:latin typeface="Aptos"/>
+              </a:defRPr>
+            </a:pPr>
+            <a:r>
+              <a:rPr sz="1800" b="1">
+                <a:solidFill>
+                  <a:srgbClr val="264741"/>
+                </a:solidFill>
+                <a:latin typeface="Aptos"/>
+              </a:rPr>
+              <a:t>Adversarial NLI: </a:t>
+            </a:r>
+            <a:r>
+              <a:rPr sz="1700" b="0">
+                <a:solidFill>
+                  <a:srgbClr val="233033"/>
+                </a:solidFill>
+                <a:latin typeface="Aptos"/>
+              </a:rPr>
+              <a:t>ANLI v2: ~19k / 47k / 103k examples; dev/test checked, training not fully verified.</a:t>
+            </a:r>
+          </a:p>
+          <a:p>
+            <a:pPr>
+              <a:spcAft>
+                <a:spcPts val="1300"/>
+              </a:spcAft>
+              <a:defRPr sz="1800">
+                <a:solidFill>
+                  <a:srgbClr val="233033"/>
+                </a:solidFill>
+                <a:latin typeface="Aptos"/>
+              </a:defRPr>
+            </a:pPr>
+            <a:r>
+              <a:rPr sz="1800" b="1">
+                <a:solidFill>
+                  <a:srgbClr val="264741"/>
+                </a:solidFill>
+                <a:latin typeface="Aptos"/>
+              </a:rPr>
+              <a:t>Abstention is not verification: </a:t>
+            </a:r>
+            <a:r>
+              <a:rPr sz="1700" b="0">
+                <a:solidFill>
+                  <a:srgbClr val="233033"/>
+                </a:solidFill>
+                <a:latin typeface="Aptos"/>
+              </a:rPr>
+              <a:t>Varshney et al. (17 datasets): no method consistently beats MaxProb across IID/OOD/ADV.</a:t>
+            </a:r>
+          </a:p>
+        </p:txBody>
+      </p:sp>
+      <p:sp>
+        <p:nvSpPr>
+          <p:cNvPr id="4" name="TextBox 3"/>
+          <p:cNvSpPr txBox="1"/>
+          <p:nvPr/>
+        </p:nvSpPr>
+        <p:spPr>
+          <a:xfrm>
+            <a:off x="411480" y="6327648"/>
+            <a:ext cx="10972800" cy="256032"/>
+          </a:xfrm>
+          <a:prstGeom prst="rect">
+            <a:avLst/>
+          </a:prstGeom>
+          <a:noFill/>
+        </p:spPr>
+        <p:txBody>
+          <a:bodyPr wrap="none">
+            <a:spAutoFit/>
+          </a:bodyPr>
+          <a:lstStyle/>
+          <a:p>
+            <a:pPr algn="r"/>
+            <a:r>
+              <a:rPr sz="900" b="1">
+                <a:solidFill>
+                  <a:srgbClr val="964630"/>
+                </a:solidFill>
+                <a:latin typeface="Aptos"/>
+              </a:rPr>
+              <a:t>CURRENT AUDIT NOTES • SELECTED SOURCES • NOVELTY UNRESOLVED</a:t>
+            </a:r>
+          </a:p>
+        </p:txBody>
+      </p:sp>
+    </p:spTree>
+  </p:cSld>
+  <p:clrMapOvr>
+    <a:masterClrMapping/>
+  </p:clrMapOvr>
+</p:sld>
+</file>
+
+<file path=ppt/slides/slide25.xml><?xml version="1.0" encoding="utf-8"?>
+<p:sld xmlns:a="http://schemas.openxmlformats.org/drawingml/2006/main" xmlns:p="http://schemas.openxmlformats.org/presentationml/2006/main" xmlns:r="http://schemas.openxmlformats.org/officeDocument/2006/relationships">
+  <p:cSld>
+    <p:spTree>
+      <p:nvGrpSpPr>
+        <p:cNvPr id="1" name=""/>
+        <p:cNvGrpSpPr/>
+        <p:nvPr/>
+      </p:nvGrpSpPr>
+      <p:grpSpPr/>
+      <p:sp>
+        <p:nvSpPr>
+          <p:cNvPr id="2" name="Title 1"/>
+          <p:cNvSpPr>
+            <a:spLocks noGrp="1"/>
+          </p:cNvSpPr>
+          <p:nvPr>
+            <p:ph type="title"/>
+          </p:nvPr>
+        </p:nvSpPr>
+        <p:spPr/>
+        <p:txBody>
+          <a:bodyPr/>
+          <a:lstStyle/>
+          <a:p>
+            <a:r>
+              <a:rPr sz="2500" b="1">
+                <a:solidFill>
+                  <a:srgbClr val="264741"/>
+                </a:solidFill>
+                <a:latin typeface="Aptos"/>
+              </a:rPr>
+              <a:t>Gate stays open • no novelty verdict</a:t>
+            </a:r>
+          </a:p>
+        </p:txBody>
+      </p:sp>
+      <p:sp>
+        <p:nvSpPr>
+          <p:cNvPr id="3" name="Content Placeholder 2"/>
+          <p:cNvSpPr>
+            <a:spLocks noGrp="1"/>
+          </p:cNvSpPr>
+          <p:nvPr>
+            <p:ph idx="1"/>
+          </p:nvPr>
+        </p:nvSpPr>
+        <p:spPr/>
+        <p:txBody>
+          <a:bodyPr wrap="square"/>
+          <a:lstStyle/>
+          <a:p>
+            <a:pPr>
+              <a:spcAft>
+                <a:spcPts val="1300"/>
+              </a:spcAft>
+              <a:defRPr sz="1800">
+                <a:solidFill>
+                  <a:srgbClr val="233033"/>
+                </a:solidFill>
+                <a:latin typeface="Aptos"/>
+              </a:defRPr>
+            </a:pPr>
+            <a:r>
+              <a:rPr sz="1800" b="1">
+                <a:solidFill>
+                  <a:srgbClr val="264741"/>
+                </a:solidFill>
+                <a:latin typeface="Aptos"/>
+              </a:rPr>
+              <a:t>Broad novelty is unsafe: </a:t>
+            </a:r>
+            <a:r>
+              <a:rPr sz="1700" b="0">
+                <a:solidFill>
+                  <a:srgbClr val="233033"/>
+                </a:solidFill>
+                <a:latin typeface="Aptos"/>
+              </a:rPr>
+              <a:t>Classification, evidence-aware handling, defer/abstain, conflict preservation and async supersession each have close prior art.</a:t>
+            </a:r>
+          </a:p>
+          <a:p>
+            <a:pPr>
+              <a:spcAft>
+                <a:spcPts val="1300"/>
+              </a:spcAft>
+              <a:defRPr sz="1800">
+                <a:solidFill>
+                  <a:srgbClr val="233033"/>
+                </a:solidFill>
+                <a:latin typeface="Aptos"/>
+              </a:defRPr>
+            </a:pPr>
+            <a:r>
+              <a:rPr sz="1800" b="1">
+                <a:solidFill>
+                  <a:srgbClr val="264741"/>
+                </a:solidFill>
+                <a:latin typeface="Aptos"/>
+              </a:rPr>
+              <a:t>Candidate comparison remains untested: </a:t>
+            </a:r>
+            <a:r>
+              <a:rPr sz="1700" b="0">
+                <a:solidFill>
+                  <a:srgbClr val="233033"/>
+                </a:solidFill>
+                <a:latin typeface="Aptos"/>
+              </a:rPr>
+              <a:t>Same-key relation + evidence-based Verify vs fixed-winner vs preserve-unresolved under async reordering, with defined convergence outputs.</a:t>
+            </a:r>
+          </a:p>
+          <a:p>
+            <a:pPr>
+              <a:spcAft>
+                <a:spcPts val="1300"/>
+              </a:spcAft>
+              <a:defRPr sz="1800">
+                <a:solidFill>
+                  <a:srgbClr val="233033"/>
+                </a:solidFill>
+                <a:latin typeface="Aptos"/>
+              </a:defRPr>
+            </a:pPr>
+            <a:r>
+              <a:rPr sz="1800" b="1">
+                <a:solidFill>
+                  <a:srgbClr val="264741"/>
+                </a:solidFill>
+                <a:latin typeface="Aptos"/>
+              </a:rPr>
+              <a:t>WH-1/2/3: </a:t>
+            </a:r>
+            <a:r>
+              <a:rPr sz="1700" b="0">
+                <a:solidFill>
+                  <a:srgbClr val="233033"/>
+                </a:solidFill>
+                <a:latin typeface="Aptos"/>
+              </a:rPr>
+              <a:t>Exact authoritative definitions are missing; leave undefined and obtain the source wording.</a:t>
+            </a:r>
+          </a:p>
+          <a:p>
+            <a:pPr>
+              <a:spcAft>
+                <a:spcPts val="1300"/>
+              </a:spcAft>
+              <a:defRPr sz="1800">
+                <a:solidFill>
+                  <a:srgbClr val="233033"/>
+                </a:solidFill>
+                <a:latin typeface="Aptos"/>
+              </a:defRPr>
+            </a:pPr>
+            <a:r>
+              <a:rPr sz="1800" b="1">
+                <a:solidFill>
+                  <a:srgbClr val="264741"/>
+                </a:solidFill>
+                <a:latin typeface="Aptos"/>
+              </a:rPr>
+              <a:t>Scope of this appendix: </a:t>
+            </a:r>
+            <a:r>
+              <a:rPr sz="1700" b="0">
+                <a:solidFill>
+                  <a:srgbClr val="233033"/>
+                </a:solidFill>
+                <a:latin typeface="Aptos"/>
+              </a:rPr>
+              <a:t>Targeted excerpts, not full source/appendix audits or independent reproduction. Pack remains provisional; no implementation or convergence proof claimed.</a:t>
+            </a:r>
+          </a:p>
+        </p:txBody>
+      </p:sp>
+      <p:sp>
+        <p:nvSpPr>
+          <p:cNvPr id="4" name="TextBox 3"/>
+          <p:cNvSpPr txBox="1"/>
+          <p:nvPr/>
+        </p:nvSpPr>
+        <p:spPr>
+          <a:xfrm>
+            <a:off x="411480" y="6327648"/>
+            <a:ext cx="10972800" cy="256032"/>
+          </a:xfrm>
+          <a:prstGeom prst="rect">
+            <a:avLst/>
+          </a:prstGeom>
+          <a:noFill/>
+        </p:spPr>
+        <p:txBody>
+          <a:bodyPr wrap="none">
+            <a:spAutoFit/>
+          </a:bodyPr>
+          <a:lstStyle/>
+          <a:p>
+            <a:pPr algn="r"/>
+            <a:r>
+              <a:rPr sz="900" b="1">
+                <a:solidFill>
+                  <a:srgbClr val="964630"/>
+                </a:solidFill>
+                <a:latin typeface="Aptos"/>
+              </a:rPr>
+              <a:t>CURRENT AUDIT NOTES • SELECTED SOURCES • NOVELTY UNRESOLVED</a:t>
             </a:r>
           </a:p>
         </p:txBody>

</xml_diff>

<commit_message>
docs: record five-source AVA literature audit
</commit_message>
<xml_diff>
--- a/docs/review-pack/AVA_Evaluation_Review_Slides.pptx
+++ b/docs/review-pack/AVA_Evaluation_Review_Slides.pptx
@@ -8663,7 +8663,7 @@
               </a:defRPr>
             </a:pPr>
             <a:r>
-              <a:t>Interpretation: substantial overlap exists; novelty remains unresolved pending full source-wide verification.</a:t>
+              <a:t>Five required papers now have source-wide primary-text audits; wider comparison and the novelty gate remain open.</a:t>
             </a:r>
           </a:p>
         </p:txBody>
@@ -11159,7 +11159,7 @@
               </a:defRPr>
             </a:pPr>
             <a:r>
-              <a:t>full texts, appendices, active disconfirmation</a:t>
+              <a:t>integrate five source-wide audits; finish residual checks</a:t>
             </a:r>
           </a:p>
         </p:txBody>
@@ -19428,7 +19428,7 @@
                 </a:solidFill>
                 <a:latin typeface="Aptos"/>
               </a:rPr>
-              <a:t>CURRENT AUDIT NOTES • SELECTED SOURCES • NOVELTY UNRESOLVED</a:t>
+              <a:t>FIVE REQUIRED SOURCE-WIDE AUDITS • WIDER GATE OPEN • NOVELTY UNRESOLVED</a:t>
             </a:r>
           </a:p>
         </p:txBody>
@@ -19648,7 +19648,7 @@
                 </a:solidFill>
                 <a:latin typeface="Aptos"/>
               </a:rPr>
-              <a:t>CURRENT AUDIT NOTES • SELECTED SOURCES • NOVELTY UNRESOLVED</a:t>
+              <a:t>FIVE REQUIRED SOURCE-WIDE AUDITS • WIDER GATE OPEN • NOVELTY UNRESOLVED</a:t>
             </a:r>
           </a:p>
         </p:txBody>
@@ -19771,7 +19771,7 @@
                 </a:solidFill>
                 <a:latin typeface="Aptos"/>
               </a:rPr>
-              <a:t>Table 3 (282): conservative 64.9% accuracy / recall 100% / false-certainty 2.1%; aggressive 97.5% / 100% / 2.5%. Table 4 (50): success 80%→100%, false-certainty 20%→0%, 2.4 calls, 0 cost; controlled, not async convergence.</a:t>
+              <a:t>Table 3 (282): conservative 64.9% accuracy / recall 100% / false-certainty 2.1%; aggressive 97.5% / 100% / 2.5%. Table 4 (50): conservative StateFuse and flat go 80%→100%; collapsed 40%→60% with 40% post-Verify false confidence. Controlled, not async convergence.</a:t>
             </a:r>
           </a:p>
           <a:p>
@@ -19868,7 +19868,7 @@
                 </a:solidFill>
                 <a:latin typeface="Aptos"/>
               </a:rPr>
-              <a:t>CURRENT AUDIT NOTES • SELECTED SOURCES • NOVELTY UNRESOLVED</a:t>
+              <a:t>FIVE REQUIRED SOURCE-WIDE AUDITS • WIDER GATE OPEN • NOVELTY UNRESOLVED</a:t>
             </a:r>
           </a:p>
         </p:txBody>
@@ -20022,7 +20022,7 @@
                 </a:solidFill>
                 <a:latin typeface="Aptos"/>
               </a:rPr>
-              <a:t>ANLI v2: ~19k / 47k / 103k examples; dev/test checked, training not fully verified.</a:t>
+              <a:t>ANLI v2: full main text checked; no appendix identified; not an AVA state-conflict dataset.</a:t>
             </a:r>
           </a:p>
           <a:p>
@@ -20088,7 +20088,7 @@
                 </a:solidFill>
                 <a:latin typeface="Aptos"/>
               </a:rPr>
-              <a:t>CURRENT AUDIT NOTES • SELECTED SOURCES • NOVELTY UNRESOLVED</a:t>
+              <a:t>FIVE REQUIRED SOURCE-WIDE AUDITS • WIDER GATE OPEN • NOVELTY UNRESOLVED</a:t>
             </a:r>
           </a:p>
         </p:txBody>
@@ -20273,7 +20273,7 @@
                 </a:solidFill>
                 <a:latin typeface="Aptos"/>
               </a:rPr>
-              <a:t>Targeted excerpts, not full source/appendix audits or independent reproduction. Pack remains provisional; no implementation or convergence proof claimed.</a:t>
+              <a:t>Five required papers have source-wide primary-text audits; wider checks, level-P review and missing artifacts remain. No independent reproduction, implementation or convergence proof is claimed.</a:t>
             </a:r>
           </a:p>
         </p:txBody>
@@ -20308,7 +20308,7 @@
                 </a:solidFill>
                 <a:latin typeface="Aptos"/>
               </a:rPr>
-              <a:t>CURRENT AUDIT NOTES • SELECTED SOURCES • NOVELTY UNRESOLVED</a:t>
+              <a:t>FIVE REQUIRED SOURCE-WIDE AUDITS • WIDER GATE OPEN • NOVELTY UNRESOLVED</a:t>
             </a:r>
           </a:p>
         </p:txBody>

</xml_diff>